<commit_message>
third pass, everythign looks much better, neets some final polish to be perfect though.
</commit_message>
<xml_diff>
--- a/happyvale_brochure_v2.pptx
+++ b/happyvale_brochure_v2.pptx
@@ -938,7 +938,7 @@
                 </a:solidFill>
                 <a:latin typeface="Nimbus Roman"/>
               </a:rPr>
-              <a:t>Welcoming façade and driveway frame this cathedral-entry townhome.</a:t>
+              <a:t>Front-facing garage and entry with a neat lawn and inviting driveway curb appeal.</a:t>
             </a:r>
             <a:endParaRPr lang="en-CA" sz="1000" b="0" u="none" strike="noStrike">
               <a:solidFill>
@@ -994,7 +994,7 @@
                 </a:solidFill>
                 <a:latin typeface="Nimbus Roman"/>
               </a:rPr>
-              <a:t>Front entry and double garage deliver impressive curb appeal and easy parking.</a:t>
+              <a:t>Bright kitchen with abundant cabinetry, neutral finishes, and natural light for everyday.</a:t>
             </a:r>
             <a:endParaRPr lang="en-CA" sz="1000" b="0" u="none" strike="noStrike">
               <a:solidFill>
@@ -1050,7 +1050,7 @@
                 </a:solidFill>
                 <a:latin typeface="Nimbus Roman"/>
               </a:rPr>
-              <a:t>A spacious fenced backyard offers green views for relaxed outdoor gatherings.</a:t>
+              <a:t>Covered deck for relaxing outdoors with a view of lush greenery and a convenient setup.</a:t>
             </a:r>
             <a:endParaRPr lang="en-CA" sz="1000" b="0" u="none" strike="noStrike">
               <a:solidFill>
@@ -1106,7 +1106,7 @@
                 </a:solidFill>
                 <a:latin typeface="Nimbus Roman"/>
               </a:rPr>
-              <a:t>Bright, modern kitchen boasts ample cabinetry and an open, functional layout.</a:t>
+              <a:t>Comfortable primary bedroom featuring a statement upholstered headboard and calm, bright.</a:t>
             </a:r>
             <a:endParaRPr lang="en-CA" sz="1000" b="0" u="none" strike="noStrike">
               <a:solidFill>
@@ -1162,7 +1162,7 @@
                 </a:solidFill>
                 <a:latin typeface="Nimbus Roman"/>
               </a:rPr>
-              <a:t>Primary bedroom feels cozy and stylish with natural light and room to unwind.</a:t>
+              <a:t>Bright, grassy backyard with mature shade tree and fencing that adds everyday privacy.</a:t>
             </a:r>
             <a:endParaRPr lang="en-CA" sz="1000" b="0" u="none" strike="noStrike">
               <a:solidFill>
@@ -1270,7 +1270,7 @@
                 </a:solidFill>
                 <a:latin typeface="Nimbus Roman"/>
               </a:rPr>
-              <a:t>Cathedral-entry 3-level split townhome with 4 bedrooms and 2 bathrooms.</a:t>
+              <a:t>Bright, functional 3-level split townhome on desirable Happyvale Avenue backing onto school-district land for added privacy.</a:t>
             </a:r>
             <a:endParaRPr lang="en-CA" sz="1100" b="0" u="none" strike="noStrike">
               <a:solidFill>
@@ -1297,7 +1297,7 @@
                 </a:solidFill>
                 <a:latin typeface="Nimbus Roman"/>
               </a:rPr>
-              <a:t>Forced-air heating with central air delivers year-round comfort.</a:t>
+              <a:t>Enjoy over 1,700 sq. ft. with a practical layout for families or flexible work-from-home living spaces.</a:t>
             </a:r>
           </a:p>
           <a:p>
@@ -1316,7 +1316,7 @@
                 </a:solidFill>
                 <a:latin typeface="Nimbus Roman"/>
               </a:rPr>
-              <a:t>Double attached garage plus 4 parking spaces; fenced yard with green outlook.</a:t>
+              <a:t>Double garage plus four total parking spaces, including an assigned stall and driveway parking for everyday convenience.</a:t>
             </a:r>
           </a:p>
           <a:p>
@@ -1335,7 +1335,7 @@
                 </a:solidFill>
                 <a:latin typeface="Nimbus Roman"/>
               </a:rPr>
-              <a:t>2012 renovations refreshed the kitchen, flooring, windows, roof, and deck.</a:t>
+              <a:t>Renovated in 2012 with kitchen updates and improvements including flooring, windows, roof, decks, and railings.</a:t>
             </a:r>
           </a:p>
           <a:p>
@@ -1354,26 +1354,7 @@
                 </a:solidFill>
                 <a:latin typeface="Nimbus Roman"/>
               </a:rPr>
-              <a:t>Pet- and rental-friendly strata with exterior maintenance handled for you.</a:t>
-            </a:r>
-          </a:p>
-          <a:p>
-            <a:pPr marL="216000" indent="-216000">
-              <a:buClr>
-                <a:srgbClr val="000000"/>
-              </a:buClr>
-              <a:buSzPct val="70000"/>
-              <a:buFont typeface="Wingdings" charset="2"/>
-              <a:buChar char=""/>
-            </a:pPr>
-            <a:r>
-              <a:rPr b="1" i="1" sz="1100">
-                <a:solidFill>
-                  <a:srgbClr val="000000"/>
-                </a:solidFill>
-                <a:latin typeface="Nimbus Roman"/>
-              </a:rPr>
-              <a:t>Near schools, shopping, and McArthur Island Park along River’s Trail.</a:t>
+              <a:t>Pet- and rental-friendly complex with strata fees covering contingency reserve, insurance, maintenance, and utilities.</a:t>
             </a:r>
           </a:p>
         </p:txBody>
@@ -1455,7 +1436,7 @@
                 </a:solidFill>
                 <a:latin typeface="Nimbus Roman"/>
               </a:rPr>
-              <a:t>Renovated Cathedral-Entry Townhome with Park Views in Brocklehurst</a:t>
+              <a:t>4-1616 Happyvale Ave: Family-Ready Split Townhome With Privacy and Double Garage</a:t>
             </a:r>
             <a:endParaRPr lang="en-CA" sz="1600" b="0" u="none" strike="noStrike">
               <a:solidFill>
@@ -1585,7 +1566,7 @@
       </p:pic>
       <p:pic>
         <p:nvPicPr>
-          <p:cNvPr id="29" name="Picture 28" descr="DSC03356.jpg"/>
+          <p:cNvPr id="29" name="Picture 28" descr="DSC03381.jpg"/>
           <p:cNvPicPr>
             <a:picLocks noChangeAspect="1"/>
           </p:cNvPicPr>
@@ -1635,7 +1616,7 @@
       </p:pic>
       <p:pic>
         <p:nvPicPr>
-          <p:cNvPr id="31" name="Picture 30" descr="DSC03381.jpg"/>
+          <p:cNvPr id="31" name="Picture 30" descr="DSC03388.jpg"/>
           <p:cNvPicPr>
             <a:picLocks noChangeAspect="1"/>
           </p:cNvPicPr>
@@ -1660,7 +1641,7 @@
       </p:pic>
       <p:pic>
         <p:nvPicPr>
-          <p:cNvPr id="32" name="Picture 31" descr="DSC03369.jpg"/>
+          <p:cNvPr id="32" name="Picture 31" descr="DSC03349.jpg"/>
           <p:cNvPicPr>
             <a:picLocks noChangeAspect="1"/>
           </p:cNvPicPr>
@@ -1685,7 +1666,7 @@
       </p:pic>
       <p:pic>
         <p:nvPicPr>
-          <p:cNvPr id="33" name="Picture 32" descr="DSC03442.jpg"/>
+          <p:cNvPr id="33" name="Picture 32" descr="DSC03341.jpg"/>
           <p:cNvPicPr>
             <a:picLocks noChangeAspect="1"/>
           </p:cNvPicPr>
@@ -1778,7 +1759,7 @@
                 </a:solidFill>
                 <a:latin typeface="Nimbus Roman"/>
               </a:rPr>
-              <a:t>Comfortable living room with a large window and media-ready setup.</a:t>
+              <a:t>Cozy living room with a large window letting in light and a stylish media-wall focal point.</a:t>
             </a:r>
             <a:endParaRPr lang="en-CA" sz="1000" b="0" u="none" strike="noStrike">
               <a:solidFill>
@@ -1834,7 +1815,7 @@
                 </a:solidFill>
                 <a:latin typeface="Nimbus Roman"/>
               </a:rPr>
-              <a:t>Sunlit dining space opens to the backyard for seamless indoor-outdoor living.</a:t>
+              <a:t>Dining area flows from the kitchen and opens to backyard views through large doors.</a:t>
             </a:r>
             <a:endParaRPr lang="en-CA" sz="1000" b="0" u="none" strike="noStrike">
               <a:solidFill>
@@ -1890,7 +1871,7 @@
                 </a:solidFill>
                 <a:latin typeface="Nimbus Roman"/>
               </a:rPr>
-              <a:t>Covered deck with space for dining and a convenient gas grill hookup.</a:t>
+              <a:t>Spacious bedroom with fresh color, roomy closet storage, and easy access from the hall.</a:t>
             </a:r>
             <a:endParaRPr lang="en-CA" sz="1000" b="0" u="none" strike="noStrike">
               <a:solidFill>
@@ -1946,7 +1927,7 @@
                 </a:solidFill>
                 <a:latin typeface="Nimbus Roman"/>
               </a:rPr>
-              <a:t>Inviting rec room with great light and flexible space for everyday living.</a:t>
+              <a:t>Clean, well-lit bathroom with a spacious vanity and bright walk-in shower area.</a:t>
             </a:r>
             <a:endParaRPr lang="en-CA" sz="1000" b="0" u="none" strike="noStrike">
               <a:solidFill>
@@ -2002,7 +1983,7 @@
                 </a:solidFill>
                 <a:latin typeface="Nimbus Roman"/>
               </a:rPr>
-              <a:t>Well-lit full bathroom with storage vanity and a practical tub/shower.</a:t>
+              <a:t>Inviting living room seating in a bright, airy layout made for relaxing and hosting.</a:t>
             </a:r>
             <a:endParaRPr lang="en-CA" sz="1000" b="0" u="none" strike="noStrike">
               <a:solidFill>
@@ -2158,7 +2139,7 @@
                 </a:solidFill>
                 <a:latin typeface="Nimbus Roman"/>
               </a:rPr>
-              <a:t>Location:	Kamloops and District</a:t>
+              <a:t>Location:	KAM - Brocklehurst</a:t>
             </a:r>
             <a:endParaRPr lang="en-CA" sz="1400" b="0" u="none" strike="noStrike">
               <a:solidFill>
@@ -2188,7 +2169,7 @@
                 </a:solidFill>
                 <a:latin typeface="Nimbus Roman"/>
               </a:rPr>
-              <a:t>	KAM - Brocklehurst</a:t>
+              <a:t>Style:	Cathedral Entry</a:t>
             </a:r>
           </a:p>
           <a:p>
@@ -2210,7 +2191,7 @@
                 </a:solidFill>
                 <a:latin typeface="Nimbus Roman"/>
               </a:rPr>
-              <a:t>Style:	Cathedral Entry</a:t>
+              <a:t>Heating:	Forced Air</a:t>
             </a:r>
           </a:p>
           <a:p>
@@ -2232,7 +2213,7 @@
                 </a:solidFill>
                 <a:latin typeface="Nimbus Roman"/>
               </a:rPr>
-              <a:t>Heating:	Forced Air</a:t>
+              <a:t>	Central Air</a:t>
             </a:r>
           </a:p>
           <a:p>
@@ -2254,7 +2235,7 @@
                 </a:solidFill>
                 <a:latin typeface="Nimbus Roman"/>
               </a:rPr>
-              <a:t>	Central Air</a:t>
+              <a:t>Includes:	Dishwasher</a:t>
             </a:r>
           </a:p>
           <a:p>
@@ -2276,7 +2257,7 @@
                 </a:solidFill>
                 <a:latin typeface="Nimbus Roman"/>
               </a:rPr>
-              <a:t>Parking:	Garage - Attached</a:t>
+              <a:t>	Electric Range</a:t>
             </a:r>
           </a:p>
           <a:p>
@@ -2298,7 +2279,7 @@
                 </a:solidFill>
                 <a:latin typeface="Nimbus Roman"/>
               </a:rPr>
-              <a:t>	2.0 Garage Spaces</a:t>
+              <a:t>	Refrigerator</a:t>
             </a:r>
           </a:p>
           <a:p>
@@ -2320,7 +2301,7 @@
                 </a:solidFill>
                 <a:latin typeface="Nimbus Roman"/>
               </a:rPr>
-              <a:t>	4 Total Parking Spaces</a:t>
+              <a:t>	Washer/Dryer</a:t>
             </a:r>
           </a:p>
           <a:p>
@@ -2342,138 +2323,6 @@
                 </a:solidFill>
                 <a:latin typeface="Nimbus Roman"/>
               </a:rPr>
-              <a:t>Includes:	Dishwasher</a:t>
-            </a:r>
-          </a:p>
-          <a:p>
-            <a:pPr>
-              <a:lnSpc>
-                <a:spcPct val="200000"/>
-              </a:lnSpc>
-              <a:tabLst>
-                <a:tab algn="l" pos="0"/>
-                <a:tab algn="l" pos="347040"/>
-                <a:tab algn="l" pos="898200"/>
-                <a:tab algn="l" pos="4027680"/>
-              </a:tabLst>
-            </a:pPr>
-            <a:r>
-              <a:rPr b="1" sz="1400">
-                <a:solidFill>
-                  <a:srgbClr val="000000"/>
-                </a:solidFill>
-                <a:latin typeface="Nimbus Roman"/>
-              </a:rPr>
-              <a:t>	Electric Range</a:t>
-            </a:r>
-          </a:p>
-          <a:p>
-            <a:pPr>
-              <a:lnSpc>
-                <a:spcPct val="200000"/>
-              </a:lnSpc>
-              <a:tabLst>
-                <a:tab algn="l" pos="0"/>
-                <a:tab algn="l" pos="347040"/>
-                <a:tab algn="l" pos="898200"/>
-                <a:tab algn="l" pos="4027680"/>
-              </a:tabLst>
-            </a:pPr>
-            <a:r>
-              <a:rPr b="1" sz="1400">
-                <a:solidFill>
-                  <a:srgbClr val="000000"/>
-                </a:solidFill>
-                <a:latin typeface="Nimbus Roman"/>
-              </a:rPr>
-              <a:t>	Refrigerator</a:t>
-            </a:r>
-          </a:p>
-          <a:p>
-            <a:pPr>
-              <a:lnSpc>
-                <a:spcPct val="200000"/>
-              </a:lnSpc>
-              <a:tabLst>
-                <a:tab algn="l" pos="0"/>
-                <a:tab algn="l" pos="347040"/>
-                <a:tab algn="l" pos="898200"/>
-                <a:tab algn="l" pos="4027680"/>
-              </a:tabLst>
-            </a:pPr>
-            <a:r>
-              <a:rPr b="1" sz="1400">
-                <a:solidFill>
-                  <a:srgbClr val="000000"/>
-                </a:solidFill>
-                <a:latin typeface="Nimbus Roman"/>
-              </a:rPr>
-              <a:t>	Washer/Dryer</a:t>
-            </a:r>
-          </a:p>
-          <a:p>
-            <a:pPr>
-              <a:lnSpc>
-                <a:spcPct val="200000"/>
-              </a:lnSpc>
-              <a:tabLst>
-                <a:tab algn="l" pos="0"/>
-                <a:tab algn="l" pos="347040"/>
-                <a:tab algn="l" pos="898200"/>
-                <a:tab algn="l" pos="4027680"/>
-              </a:tabLst>
-            </a:pPr>
-            <a:r>
-              <a:rPr b="1" sz="1400">
-                <a:solidFill>
-                  <a:srgbClr val="000000"/>
-                </a:solidFill>
-                <a:latin typeface="Nimbus Roman"/>
-              </a:rPr>
-              <a:t>Age:	Built 1983</a:t>
-            </a:r>
-          </a:p>
-          <a:p>
-            <a:pPr>
-              <a:lnSpc>
-                <a:spcPct val="200000"/>
-              </a:lnSpc>
-              <a:tabLst>
-                <a:tab algn="l" pos="0"/>
-                <a:tab algn="l" pos="347040"/>
-                <a:tab algn="l" pos="898200"/>
-                <a:tab algn="l" pos="4027680"/>
-              </a:tabLst>
-            </a:pPr>
-            <a:r>
-              <a:rPr b="1" sz="1400">
-                <a:solidFill>
-                  <a:srgbClr val="000000"/>
-                </a:solidFill>
-                <a:latin typeface="Nimbus Roman"/>
-              </a:rPr>
-              <a:t>	Renovated 2012</a:t>
-            </a:r>
-          </a:p>
-          <a:p>
-            <a:pPr>
-              <a:lnSpc>
-                <a:spcPct val="200000"/>
-              </a:lnSpc>
-              <a:tabLst>
-                <a:tab algn="l" pos="0"/>
-                <a:tab algn="l" pos="347040"/>
-                <a:tab algn="l" pos="898200"/>
-                <a:tab algn="l" pos="4027680"/>
-              </a:tabLst>
-            </a:pPr>
-            <a:r>
-              <a:rPr b="1" sz="1400">
-                <a:solidFill>
-                  <a:srgbClr val="000000"/>
-                </a:solidFill>
-                <a:latin typeface="Nimbus Roman"/>
-              </a:rPr>
               <a:t>Taxes:	$3,145 (2025)</a:t>
             </a:r>
           </a:p>
@@ -2518,7 +2367,7 @@
                 </a:solidFill>
                 <a:latin typeface="Nimbus Roman"/>
               </a:rPr>
-              <a:t>Main (Area not specified)</a:t>
+              <a:t>Main (1,046 sq. ft.)</a:t>
             </a:r>
             <a:endParaRPr lang="en-CA" sz="1400" b="0" u="none" strike="noStrike">
               <a:solidFill>
@@ -2626,6 +2475,26 @@
             </a:r>
           </a:p>
           <a:p>
+            <a:pPr algn="ctr">
+              <a:lnSpc>
+                <a:spcPct val="150000"/>
+              </a:lnSpc>
+              <a:tabLst>
+                <a:tab algn="l" pos="1619280"/>
+              </a:tabLst>
+            </a:pPr>
+            <a:r>
+              <a:rPr b="1" sz="1400" i="1">
+                <a:solidFill>
+                  <a:srgbClr val="000000"/>
+                </a:solidFill>
+                <a:latin typeface="Nimbus Roman"/>
+              </a:rPr>
+              <a:t>Lower (674.9 sq. ft.)</a:t>
+            </a:r>
+          </a:p>
+          <a:p/>
+          <a:p>
             <a:pPr>
               <a:lnSpc>
                 <a:spcPct val="150000"/>
@@ -2641,7 +2510,7 @@
                 </a:solidFill>
                 <a:latin typeface="Nimbus Roman"/>
               </a:rPr>
-              <a:t>Bathroom - Full (4 PCE)	</a:t>
+              <a:t>Bedroom	12' 7" x 12' 9"</a:t>
             </a:r>
           </a:p>
           <a:p>
@@ -2660,7 +2529,7 @@
                 </a:solidFill>
                 <a:latin typeface="Nimbus Roman"/>
               </a:rPr>
-              <a:t>Ensuite - Half (2 PCE)	</a:t>
+              <a:t>Bathroom	4 piece</a:t>
             </a:r>
           </a:p>
           <a:p>
@@ -2679,29 +2548,9 @@
                 </a:solidFill>
                 <a:latin typeface="Nimbus Roman"/>
               </a:rPr>
-              <a:t>Laundry	9' 3" x 3' </a:t>
-            </a:r>
-          </a:p>
-          <a:p>
-            <a:pPr algn="ctr">
-              <a:lnSpc>
-                <a:spcPct val="150000"/>
-              </a:lnSpc>
-              <a:tabLst>
-                <a:tab algn="l" pos="1619280"/>
-              </a:tabLst>
-            </a:pPr>
-            <a:r>
-              <a:rPr b="1" sz="1400" i="1">
-                <a:solidFill>
-                  <a:srgbClr val="000000"/>
-                </a:solidFill>
-                <a:latin typeface="Nimbus Roman"/>
-              </a:rPr>
-              <a:t>Lower (Area not specified)</a:t>
-            </a:r>
-          </a:p>
-          <a:p/>
+              <a:t>Ensuite	2 piece</a:t>
+            </a:r>
+          </a:p>
           <a:p>
             <a:pPr>
               <a:lnSpc>
@@ -2718,7 +2567,7 @@
                 </a:solidFill>
                 <a:latin typeface="Nimbus Roman"/>
               </a:rPr>
-              <a:t>Family Room	19' 3" x 12' 6"</a:t>
+              <a:t>Laundry	9' 3" x 3'</a:t>
             </a:r>
           </a:p>
           <a:p>
@@ -2737,7 +2586,7 @@
                 </a:solidFill>
                 <a:latin typeface="Nimbus Roman"/>
               </a:rPr>
-              <a:t>Bedroom	12' 7" x 12' 9" 8' 9"</a:t>
+              <a:t>Family Room	19' 3" x 12' 6"</a:t>
             </a:r>
           </a:p>
           <a:p>
@@ -2756,17 +2605,7 @@
                 </a:solidFill>
                 <a:latin typeface="Nimbus Roman"/>
               </a:rPr>
-              <a:t>Storage	18' 9" x 6' </a:t>
-            </a:r>
-          </a:p>
-          <a:p>
-            <a:r>
-              <a:t>*All measurements approximate*</a:t>
-            </a:r>
-          </a:p>
-          <a:p>
-            <a:r>
-              <a:t>Size taken from Land Title Buyer to verify</a:t>
+              <a:t>Storage	18' 9" x 6'</a:t>
             </a:r>
           </a:p>
         </p:txBody>
@@ -2818,7 +2657,7 @@
       </p:sp>
       <p:pic>
         <p:nvPicPr>
-          <p:cNvPr id="43" name="Picture 42" descr="DSC03378.jpg"/>
+          <p:cNvPr id="43" name="Picture 42" descr="DSC03369.jpg"/>
           <p:cNvPicPr>
             <a:picLocks noChangeAspect="1"/>
           </p:cNvPicPr>
@@ -2843,7 +2682,7 @@
       </p:pic>
       <p:pic>
         <p:nvPicPr>
-          <p:cNvPr id="44" name="Picture 43" descr="DSC03388.jpg"/>
+          <p:cNvPr id="44" name="Picture 43" descr="DSC03378.jpg"/>
           <p:cNvPicPr>
             <a:picLocks noChangeAspect="1"/>
           </p:cNvPicPr>
@@ -2868,7 +2707,7 @@
       </p:pic>
       <p:pic>
         <p:nvPicPr>
-          <p:cNvPr id="45" name="Picture 44" descr="DSC03399.jpg"/>
+          <p:cNvPr id="45" name="Picture 44" descr="DSC03423.jpg"/>
           <p:cNvPicPr>
             <a:picLocks noChangeAspect="1"/>
           </p:cNvPicPr>
@@ -2876,7 +2715,7 @@
         </p:nvPicPr>
         <p:blipFill>
           <a:blip r:embed="rId5"/>
-          <a:srcRect l="8910" r="8910"/>
+          <a:srcRect l="8814" r="8814"/>
           <a:stretch>
             <a:fillRect/>
           </a:stretch>
@@ -2893,7 +2732,7 @@
       </p:pic>
       <p:pic>
         <p:nvPicPr>
-          <p:cNvPr id="46" name="Picture 45" descr="DSC03428.jpg"/>
+          <p:cNvPr id="46" name="Picture 45" descr="DSC03372.jpg"/>
           <p:cNvPicPr>
             <a:picLocks noChangeAspect="1"/>
           </p:cNvPicPr>
@@ -2901,7 +2740,7 @@
         </p:nvPicPr>
         <p:blipFill>
           <a:blip r:embed="rId6"/>
-          <a:srcRect l="13715" r="13715"/>
+          <a:srcRect l="13800" r="13800"/>
           <a:stretch>
             <a:fillRect/>
           </a:stretch>
@@ -2918,7 +2757,7 @@
       </p:pic>
       <p:pic>
         <p:nvPicPr>
-          <p:cNvPr id="47" name="Picture 46" descr="DSC03434.jpg"/>
+          <p:cNvPr id="47" name="Picture 46" descr="DSC03399.jpg"/>
           <p:cNvPicPr>
             <a:picLocks noChangeAspect="1"/>
           </p:cNvPicPr>

</xml_diff>